<commit_message>
Minor updates to improve instructions
Signed-off-by: Harry Kimpel <harrykimpel@hotmail.com>
</commit_message>
<xml_diff>
--- a/xxx-AgentFrameworkObservabilityWithNewRelic/Coach/Lectures.pptx
+++ b/xxx-AgentFrameworkObservabilityWithNewRelic/Coach/Lectures.pptx
@@ -1194,7 +1194,7 @@
           <a:p>
             <a:fld id="{D2F29697-4A6D-AC4B-B035-E737BE26C24F}" type="datetimeFigureOut">
               <a:rPr lang="en-US" smtClean="0"/>
-              <a:t>1/29/26</a:t>
+              <a:t>2/4/26</a:t>
             </a:fld>
             <a:endParaRPr lang="en-US"/>
           </a:p>
@@ -1359,7 +1359,7 @@
           <a:p>
             <a:fld id="{3B795838-E26F-BF4F-AF40-5695E293B9BE}" type="datetimeFigureOut">
               <a:rPr lang="en-US" smtClean="0"/>
-              <a:t>1/29/26</a:t>
+              <a:t>2/4/26</a:t>
             </a:fld>
             <a:endParaRPr lang="en-US"/>
           </a:p>
@@ -5268,7 +5268,7 @@
           <a:p>
             <a:fld id="{DFED49D2-CC62-47A6-8FD4-1840AC422660}" type="datetimeFigureOut">
               <a:rPr lang="en-US" smtClean="0"/>
-              <a:t>1/29/26</a:t>
+              <a:t>2/4/26</a:t>
             </a:fld>
             <a:endParaRPr lang="en-US"/>
           </a:p>
@@ -5623,7 +5623,7 @@
           <a:p>
             <a:fld id="{DFED49D2-CC62-47A6-8FD4-1840AC422660}" type="datetimeFigureOut">
               <a:rPr lang="en-US" smtClean="0"/>
-              <a:t>1/29/26</a:t>
+              <a:t>2/4/26</a:t>
             </a:fld>
             <a:endParaRPr lang="en-US"/>
           </a:p>
@@ -5821,7 +5821,7 @@
           <a:p>
             <a:fld id="{DFED49D2-CC62-47A6-8FD4-1840AC422660}" type="datetimeFigureOut">
               <a:rPr lang="en-US" smtClean="0"/>
-              <a:t>1/29/26</a:t>
+              <a:t>2/4/26</a:t>
             </a:fld>
             <a:endParaRPr lang="en-US"/>
           </a:p>
@@ -6029,7 +6029,7 @@
           <a:p>
             <a:fld id="{DFED49D2-CC62-47A6-8FD4-1840AC422660}" type="datetimeFigureOut">
               <a:rPr lang="en-US" smtClean="0"/>
-              <a:t>1/29/26</a:t>
+              <a:t>2/4/26</a:t>
             </a:fld>
             <a:endParaRPr lang="en-US"/>
           </a:p>
@@ -6596,7 +6596,7 @@
           <a:p>
             <a:fld id="{DFED49D2-CC62-47A6-8FD4-1840AC422660}" type="datetimeFigureOut">
               <a:rPr lang="en-US" smtClean="0"/>
-              <a:t>1/29/26</a:t>
+              <a:t>2/4/26</a:t>
             </a:fld>
             <a:endParaRPr lang="en-US" dirty="0"/>
           </a:p>
@@ -6852,7 +6852,7 @@
           <a:p>
             <a:fld id="{DFED49D2-CC62-47A6-8FD4-1840AC422660}" type="datetimeFigureOut">
               <a:rPr lang="en-US" smtClean="0"/>
-              <a:t>1/29/26</a:t>
+              <a:t>2/4/26</a:t>
             </a:fld>
             <a:endParaRPr lang="en-US"/>
           </a:p>
@@ -7225,7 +7225,7 @@
           <a:p>
             <a:fld id="{DFED49D2-CC62-47A6-8FD4-1840AC422660}" type="datetimeFigureOut">
               <a:rPr lang="en-US" smtClean="0"/>
-              <a:t>1/29/26</a:t>
+              <a:t>2/4/26</a:t>
             </a:fld>
             <a:endParaRPr lang="en-US"/>
           </a:p>
@@ -7562,7 +7562,7 @@
           <a:p>
             <a:fld id="{DFED49D2-CC62-47A6-8FD4-1840AC422660}" type="datetimeFigureOut">
               <a:rPr lang="en-US" smtClean="0"/>
-              <a:t>1/29/26</a:t>
+              <a:t>2/4/26</a:t>
             </a:fld>
             <a:endParaRPr lang="en-US"/>
           </a:p>
@@ -7974,7 +7974,7 @@
           <a:p>
             <a:fld id="{DFED49D2-CC62-47A6-8FD4-1840AC422660}" type="datetimeFigureOut">
               <a:rPr lang="en-US" smtClean="0"/>
-              <a:t>1/29/26</a:t>
+              <a:t>2/4/26</a:t>
             </a:fld>
             <a:endParaRPr lang="en-US"/>
           </a:p>
@@ -8120,7 +8120,7 @@
           <a:p>
             <a:fld id="{DFED49D2-CC62-47A6-8FD4-1840AC422660}" type="datetimeFigureOut">
               <a:rPr lang="en-US" smtClean="0"/>
-              <a:t>1/29/26</a:t>
+              <a:t>2/4/26</a:t>
             </a:fld>
             <a:endParaRPr lang="en-US"/>
           </a:p>
@@ -8233,7 +8233,7 @@
           <a:p>
             <a:fld id="{DFED49D2-CC62-47A6-8FD4-1840AC422660}" type="datetimeFigureOut">
               <a:rPr lang="en-US" smtClean="0"/>
-              <a:t>1/29/26</a:t>
+              <a:t>2/4/26</a:t>
             </a:fld>
             <a:endParaRPr lang="en-US"/>
           </a:p>
@@ -8544,7 +8544,7 @@
           <a:p>
             <a:fld id="{DFED49D2-CC62-47A6-8FD4-1840AC422660}" type="datetimeFigureOut">
               <a:rPr lang="en-US" smtClean="0"/>
-              <a:t>1/29/26</a:t>
+              <a:t>2/4/26</a:t>
             </a:fld>
             <a:endParaRPr lang="en-US"/>
           </a:p>
@@ -8785,7 +8785,7 @@
           <a:p>
             <a:fld id="{DFED49D2-CC62-47A6-8FD4-1840AC422660}" type="datetimeFigureOut">
               <a:rPr lang="en-US" smtClean="0"/>
-              <a:t>1/29/26</a:t>
+              <a:t>2/4/26</a:t>
             </a:fld>
             <a:endParaRPr lang="en-US"/>
           </a:p>
@@ -9853,7 +9853,7 @@
         <p:spPr/>
         <p:txBody>
           <a:bodyPr>
-            <a:normAutofit/>
+            <a:normAutofit fontScale="70000" lnSpcReduction="20000"/>
           </a:bodyPr>
           <a:lstStyle/>
           <a:p>
@@ -9865,21 +9865,36 @@
                 <a:latin typeface="Segoe UI" panose="020B0502040204020203" pitchFamily="34" charset="0"/>
                 <a:cs typeface="Segoe UI" panose="020B0502040204020203" pitchFamily="34" charset="0"/>
               </a:rPr>
-              <a:t>It's time to build the first version of </a:t>
+              <a:t>Now that you have a working MVP, it's time to add observability to your </a:t>
             </a:r>
             <a:r>
               <a:rPr lang="en-US" dirty="0" err="1">
                 <a:latin typeface="Segoe UI" panose="020B0502040204020203" pitchFamily="34" charset="0"/>
                 <a:cs typeface="Segoe UI" panose="020B0502040204020203" pitchFamily="34" charset="0"/>
               </a:rPr>
-              <a:t>WanderAI's</a:t>
+              <a:t>WanderAI</a:t>
             </a:r>
             <a:r>
               <a:rPr lang="en-US" dirty="0">
                 <a:latin typeface="Segoe UI" panose="020B0502040204020203" pitchFamily="34" charset="0"/>
                 <a:cs typeface="Segoe UI" panose="020B0502040204020203" pitchFamily="34" charset="0"/>
               </a:rPr>
-              <a:t> Travel Planner service! In this challenge, you will create a Flask web application that leverages the Microsoft Agent Framework to generate personalized travel itineraries.</a:t>
+              <a:t> agents using </a:t>
+            </a:r>
+            <a:r>
+              <a:rPr lang="en-US" dirty="0" err="1">
+                <a:latin typeface="Segoe UI" panose="020B0502040204020203" pitchFamily="34" charset="0"/>
+                <a:cs typeface="Segoe UI" panose="020B0502040204020203" pitchFamily="34" charset="0"/>
+                <a:hlinkClick r:id="rId3"/>
+              </a:rPr>
+              <a:t>OpenTelemetry</a:t>
+            </a:r>
+            <a:r>
+              <a:rPr lang="en-US" dirty="0">
+                <a:latin typeface="Segoe UI" panose="020B0502040204020203" pitchFamily="34" charset="0"/>
+                <a:cs typeface="Segoe UI" panose="020B0502040204020203" pitchFamily="34" charset="0"/>
+              </a:rPr>
+              <a:t>. Right now, if something goes wrong with your agent, you have no visibility into which tool was called, how long operations take, or how to correlate logs to specific requests.</a:t>
             </a:r>
           </a:p>
           <a:p>
@@ -9896,11 +9911,111 @@
               <a:buNone/>
             </a:pPr>
             <a:r>
+              <a:rPr lang="en-US" dirty="0" err="1">
+                <a:latin typeface="Segoe UI" panose="020B0502040204020203" pitchFamily="34" charset="0"/>
+                <a:cs typeface="Segoe UI" panose="020B0502040204020203" pitchFamily="34" charset="0"/>
+              </a:rPr>
+              <a:t>OpenTelemetry</a:t>
+            </a:r>
+            <a:r>
               <a:rPr lang="en-US" dirty="0">
                 <a:latin typeface="Segoe UI" panose="020B0502040204020203" pitchFamily="34" charset="0"/>
                 <a:cs typeface="Segoe UI" panose="020B0502040204020203" pitchFamily="34" charset="0"/>
               </a:rPr>
-              <a:t>Your application will accept user travel preferences through a web form and use an AI agent to create beautiful, customized trip plans. The agent will have access to tools that provide real-time information like weather data and current date/time.</a:t>
+              <a:t> is the industry standard for observability in modern applications. By instrumenting your application, you'll be able to see traces showing the full journey of each request, capture timing information, and add structured context to your logs.</a:t>
+            </a:r>
+          </a:p>
+          <a:p>
+            <a:pPr marL="0" indent="0">
+              <a:buNone/>
+            </a:pPr>
+            <a:endParaRPr lang="en-US" dirty="0">
+              <a:latin typeface="Segoe UI" panose="020B0502040204020203" pitchFamily="34" charset="0"/>
+              <a:cs typeface="Segoe UI" panose="020B0502040204020203" pitchFamily="34" charset="0"/>
+            </a:endParaRPr>
+          </a:p>
+          <a:p>
+            <a:pPr marL="0" indent="0">
+              <a:buNone/>
+            </a:pPr>
+            <a:r>
+              <a:rPr lang="en-US" dirty="0">
+                <a:latin typeface="Segoe UI" panose="020B0502040204020203" pitchFamily="34" charset="0"/>
+                <a:cs typeface="Segoe UI" panose="020B0502040204020203" pitchFamily="34" charset="0"/>
+              </a:rPr>
+              <a:t>Microsoft Agent Framework already integrates with </a:t>
+            </a:r>
+            <a:r>
+              <a:rPr lang="en-US" dirty="0" err="1">
+                <a:latin typeface="Segoe UI" panose="020B0502040204020203" pitchFamily="34" charset="0"/>
+                <a:cs typeface="Segoe UI" panose="020B0502040204020203" pitchFamily="34" charset="0"/>
+              </a:rPr>
+              <a:t>OpenTelemetry</a:t>
+            </a:r>
+            <a:r>
+              <a:rPr lang="en-US" dirty="0">
+                <a:latin typeface="Segoe UI" panose="020B0502040204020203" pitchFamily="34" charset="0"/>
+                <a:cs typeface="Segoe UI" panose="020B0502040204020203" pitchFamily="34" charset="0"/>
+              </a:rPr>
+              <a:t> out of the box, and more specifically Agent Framework emits traces, logs, and metrics according to the </a:t>
+            </a:r>
+            <a:r>
+              <a:rPr lang="en-US" dirty="0" err="1">
+                <a:latin typeface="Segoe UI" panose="020B0502040204020203" pitchFamily="34" charset="0"/>
+                <a:cs typeface="Segoe UI" panose="020B0502040204020203" pitchFamily="34" charset="0"/>
+                <a:hlinkClick r:id="rId4"/>
+              </a:rPr>
+              <a:t>OpenTelemetry</a:t>
+            </a:r>
+            <a:r>
+              <a:rPr lang="en-US" dirty="0">
+                <a:latin typeface="Segoe UI" panose="020B0502040204020203" pitchFamily="34" charset="0"/>
+                <a:cs typeface="Segoe UI" panose="020B0502040204020203" pitchFamily="34" charset="0"/>
+                <a:hlinkClick r:id="rId4"/>
+              </a:rPr>
+              <a:t> GenAI Semantic Conventions</a:t>
+            </a:r>
+            <a:r>
+              <a:rPr lang="en-US" dirty="0">
+                <a:latin typeface="Segoe UI" panose="020B0502040204020203" pitchFamily="34" charset="0"/>
+                <a:cs typeface="Segoe UI" panose="020B0502040204020203" pitchFamily="34" charset="0"/>
+              </a:rPr>
+              <a:t>.</a:t>
+            </a:r>
+          </a:p>
+          <a:p>
+            <a:pPr marL="0" indent="0">
+              <a:buNone/>
+            </a:pPr>
+            <a:endParaRPr lang="en-US" dirty="0">
+              <a:latin typeface="Segoe UI" panose="020B0502040204020203" pitchFamily="34" charset="0"/>
+              <a:cs typeface="Segoe UI" panose="020B0502040204020203" pitchFamily="34" charset="0"/>
+            </a:endParaRPr>
+          </a:p>
+          <a:p>
+            <a:pPr marL="0" indent="0">
+              <a:buNone/>
+            </a:pPr>
+            <a:r>
+              <a:rPr lang="en-US" dirty="0">
+                <a:latin typeface="Segoe UI" panose="020B0502040204020203" pitchFamily="34" charset="0"/>
+                <a:cs typeface="Segoe UI" panose="020B0502040204020203" pitchFamily="34" charset="0"/>
+              </a:rPr>
+              <a:t>In this challenge, you will initialize </a:t>
+            </a:r>
+            <a:r>
+              <a:rPr lang="en-US" dirty="0" err="1">
+                <a:latin typeface="Segoe UI" panose="020B0502040204020203" pitchFamily="34" charset="0"/>
+                <a:cs typeface="Segoe UI" panose="020B0502040204020203" pitchFamily="34" charset="0"/>
+              </a:rPr>
+              <a:t>OpenTelemetry</a:t>
+            </a:r>
+            <a:r>
+              <a:rPr lang="en-US" dirty="0">
+                <a:latin typeface="Segoe UI" panose="020B0502040204020203" pitchFamily="34" charset="0"/>
+                <a:cs typeface="Segoe UI" panose="020B0502040204020203" pitchFamily="34" charset="0"/>
+              </a:rPr>
+              <a:t>, verify telemetry in the console, and then confirm the same telemetry in New Relic before moving on to custom instrumentation in the next challenge.</a:t>
             </a:r>
           </a:p>
         </p:txBody>
@@ -10069,7 +10184,7 @@
         <p:spPr/>
         <p:txBody>
           <a:bodyPr>
-            <a:normAutofit fontScale="47500" lnSpcReduction="20000"/>
+            <a:normAutofit fontScale="70000" lnSpcReduction="20000"/>
           </a:bodyPr>
           <a:lstStyle/>
           <a:p>
@@ -10081,7 +10196,7 @@
                 <a:latin typeface="Segoe UI" panose="020B0502040204020203" pitchFamily="34" charset="0"/>
                 <a:cs typeface="Segoe UI" panose="020B0502040204020203" pitchFamily="34" charset="0"/>
               </a:rPr>
-              <a:t>Your goal is to add comprehensive </a:t>
+              <a:t>Your goal is to add basic </a:t>
             </a:r>
             <a:r>
               <a:rPr lang="en-US" sz="4600" dirty="0" err="1">
@@ -10095,7 +10210,7 @@
                 <a:latin typeface="Segoe UI" panose="020B0502040204020203" pitchFamily="34" charset="0"/>
                 <a:cs typeface="Segoe UI" panose="020B0502040204020203" pitchFamily="34" charset="0"/>
               </a:rPr>
-              <a:t> instrumentation to your travel planning application. This includes:</a:t>
+              <a:t> instrumentation to your travel planning application and validate the results:</a:t>
             </a:r>
           </a:p>
           <a:p>
@@ -10108,9 +10223,8 @@
             </a:endParaRPr>
           </a:p>
           <a:p>
-            <a:pPr marL="457200"/>
-            <a:r>
-              <a:rPr lang="en-US" sz="4600" b="1" dirty="0">
+            <a:r>
+              <a:rPr lang="en-US" sz="3500" b="1" dirty="0">
                 <a:solidFill>
                   <a:srgbClr val="F6C243"/>
                 </a:solidFill>
@@ -10118,78 +10232,58 @@
               <a:t>Initialize </a:t>
             </a:r>
             <a:r>
-              <a:rPr lang="en-US" sz="4600" b="1" dirty="0" err="1">
+              <a:rPr lang="en-US" sz="3500" b="1" dirty="0" err="1">
                 <a:solidFill>
                   <a:srgbClr val="F6C243"/>
                 </a:solidFill>
               </a:rPr>
               <a:t>OpenTelemetry</a:t>
             </a:r>
-            <a:endParaRPr lang="en-US" sz="4600" b="1" dirty="0">
+            <a:endParaRPr lang="en-US" sz="3500" b="1" dirty="0">
               <a:solidFill>
                 <a:srgbClr val="F6C243"/>
               </a:solidFill>
             </a:endParaRPr>
           </a:p>
           <a:p>
-            <a:pPr marL="914400" lvl="1"/>
-            <a:r>
-              <a:rPr lang="en-US" sz="4600" dirty="0"/>
+            <a:pPr lvl="1"/>
+            <a:r>
+              <a:rPr lang="en-US" sz="3500" dirty="0"/>
               <a:t>Set up the tracer provider and configure resource attributes to identify your service</a:t>
             </a:r>
           </a:p>
           <a:p>
-            <a:pPr marL="457200"/>
-            <a:r>
-              <a:rPr lang="en-US" sz="4600" b="1" dirty="0">
+            <a:r>
+              <a:rPr lang="en-US" sz="3500" b="1" dirty="0">
                 <a:solidFill>
                   <a:srgbClr val="F6C243"/>
                 </a:solidFill>
               </a:rPr>
-              <a:t>Instrument Tool Functions</a:t>
-            </a:r>
-          </a:p>
-          <a:p>
-            <a:pPr marL="914400" lvl="1"/>
-            <a:r>
-              <a:rPr lang="en-US" sz="4600" dirty="0"/>
-              <a:t>Wrap each tool function with a span to capture timing and attributes</a:t>
-            </a:r>
-          </a:p>
-          <a:p>
-            <a:pPr marL="457200"/>
-            <a:r>
-              <a:rPr lang="en-US" sz="4600" b="1" dirty="0">
+              <a:t>Verify Console Telemetry</a:t>
+            </a:r>
+          </a:p>
+          <a:p>
+            <a:pPr lvl="1"/>
+            <a:r>
+              <a:rPr lang="en-US" sz="3600" dirty="0"/>
+              <a:t>Confirm traces and metrics show up in your terminal</a:t>
+            </a:r>
+          </a:p>
+          <a:p>
+            <a:r>
+              <a:rPr lang="en-US" sz="3500" b="1" dirty="0">
                 <a:solidFill>
                   <a:srgbClr val="F6C243"/>
                 </a:solidFill>
               </a:rPr>
-              <a:t>Instrument Flask Routes</a:t>
-            </a:r>
-          </a:p>
-          <a:p>
-            <a:pPr marL="914400" lvl="1"/>
-            <a:r>
-              <a:rPr lang="en-US" sz="4600" dirty="0"/>
-              <a:t>Add spans to your request handlers to track the full request lifecycle</a:t>
-            </a:r>
-          </a:p>
-          <a:p>
-            <a:pPr marL="457200"/>
-            <a:r>
-              <a:rPr lang="en-US" sz="4600" b="1" dirty="0">
-                <a:solidFill>
-                  <a:srgbClr val="F6C243"/>
-                </a:solidFill>
-              </a:rPr>
-              <a:t>Add Structured Logging</a:t>
-            </a:r>
-          </a:p>
-          <a:p>
-            <a:pPr marL="914400" lvl="1"/>
-            <a:r>
-              <a:rPr lang="en-US" sz="4600" dirty="0"/>
-              <a:t>Configure logging with context that correlates to your traces</a:t>
+              <a:t>Send Telemetry to New Relic</a:t>
+            </a:r>
+          </a:p>
+          <a:p>
+            <a:pPr lvl="1"/>
+            <a:r>
+              <a:rPr lang="en-US" sz="3600" dirty="0"/>
+              <a:t>Switch exporters to OTLP and confirm the same signals in New Relic</a:t>
             </a:r>
           </a:p>
         </p:txBody>
@@ -10386,7 +10480,7 @@
             </a:br>
             <a:r>
               <a:rPr lang="en-US" dirty="0"/>
-              <a:t>- Connect to New Relic</a:t>
+              <a:t>- Custom Telemetry</a:t>
             </a:r>
           </a:p>
         </p:txBody>
@@ -10417,12 +10511,8 @@
             <a:pPr algn="ctr"/>
             <a:r>
               <a:rPr lang="en-US" dirty="0"/>
-              <a:t>Time to see the full picture!</a:t>
-            </a:r>
-          </a:p>
-          <a:p>
-            <a:pPr algn="ctr"/>
-            <a:endParaRPr lang="en-US" dirty="0"/>
+              <a:t>Add your own signals</a:t>
+            </a:r>
           </a:p>
         </p:txBody>
       </p:sp>
@@ -10481,7 +10571,7 @@
         <p:spPr/>
         <p:txBody>
           <a:bodyPr>
-            <a:normAutofit/>
+            <a:normAutofit fontScale="77500" lnSpcReduction="20000"/>
           </a:bodyPr>
           <a:lstStyle/>
           <a:p>
@@ -10493,21 +10583,7 @@
                 <a:latin typeface="Segoe UI" panose="020B0502040204020203" pitchFamily="34" charset="0"/>
                 <a:cs typeface="Segoe UI" panose="020B0502040204020203" pitchFamily="34" charset="0"/>
               </a:rPr>
-              <a:t>Console output is great for development, but in production you need a backend that can store, search, and analyze your telemetry at scale. New Relic is an observability platform that receives </a:t>
-            </a:r>
-            <a:r>
-              <a:rPr lang="en-US" dirty="0" err="1">
-                <a:latin typeface="Segoe UI" panose="020B0502040204020203" pitchFamily="34" charset="0"/>
-                <a:cs typeface="Segoe UI" panose="020B0502040204020203" pitchFamily="34" charset="0"/>
-              </a:rPr>
-              <a:t>OpenTelemetry</a:t>
-            </a:r>
-            <a:r>
-              <a:rPr lang="en-US" dirty="0">
-                <a:latin typeface="Segoe UI" panose="020B0502040204020203" pitchFamily="34" charset="0"/>
-                <a:cs typeface="Segoe UI" panose="020B0502040204020203" pitchFamily="34" charset="0"/>
-              </a:rPr>
-              <a:t> data and provides powerful tools for viewing traces, correlating across services, and collaborating with your team on debugging.</a:t>
+              <a:t>In Challenge 03, you verified that the Agent Framework automatically generates traces and metrics for your AI agent operations. Now it's time to add custom instrumentation to capture application-specific insights.</a:t>
             </a:r>
           </a:p>
           <a:p>
@@ -10528,21 +10604,115 @@
                 <a:latin typeface="Segoe UI" panose="020B0502040204020203" pitchFamily="34" charset="0"/>
                 <a:cs typeface="Segoe UI" panose="020B0502040204020203" pitchFamily="34" charset="0"/>
               </a:rPr>
-              <a:t>In this challenge, you will connect your </a:t>
+              <a:t>Custom instrumentation allows you to:</a:t>
+            </a:r>
+          </a:p>
+          <a:p>
+            <a:pPr marL="0" indent="0">
+              <a:buNone/>
+            </a:pPr>
+            <a:endParaRPr lang="en-US" dirty="0">
+              <a:latin typeface="Segoe UI" panose="020B0502040204020203" pitchFamily="34" charset="0"/>
+              <a:cs typeface="Segoe UI" panose="020B0502040204020203" pitchFamily="34" charset="0"/>
+            </a:endParaRPr>
+          </a:p>
+          <a:p>
+            <a:r>
+              <a:rPr lang="en-US" dirty="0">
+                <a:latin typeface="Segoe UI" panose="020B0502040204020203" pitchFamily="34" charset="0"/>
+                <a:cs typeface="Segoe UI" panose="020B0502040204020203" pitchFamily="34" charset="0"/>
+              </a:rPr>
+              <a:t>Create spans for specific business operations (e.g., "</a:t>
             </a:r>
             <a:r>
               <a:rPr lang="en-US" dirty="0" err="1">
                 <a:latin typeface="Segoe UI" panose="020B0502040204020203" pitchFamily="34" charset="0"/>
                 <a:cs typeface="Segoe UI" panose="020B0502040204020203" pitchFamily="34" charset="0"/>
               </a:rPr>
-              <a:t>OpenTelemetry</a:t>
+              <a:t>plan_trip</a:t>
             </a:r>
             <a:r>
               <a:rPr lang="en-US" dirty="0">
                 <a:latin typeface="Segoe UI" panose="020B0502040204020203" pitchFamily="34" charset="0"/>
                 <a:cs typeface="Segoe UI" panose="020B0502040204020203" pitchFamily="34" charset="0"/>
               </a:rPr>
-              <a:t>-instrumented application to New Relic so your entire team can see and analyze agent behavior in real-time.</a:t>
+              <a:t>", "</a:t>
+            </a:r>
+            <a:r>
+              <a:rPr lang="en-US" dirty="0" err="1">
+                <a:latin typeface="Segoe UI" panose="020B0502040204020203" pitchFamily="34" charset="0"/>
+                <a:cs typeface="Segoe UI" panose="020B0502040204020203" pitchFamily="34" charset="0"/>
+              </a:rPr>
+              <a:t>validate_itinerary</a:t>
+            </a:r>
+            <a:r>
+              <a:rPr lang="en-US" dirty="0">
+                <a:latin typeface="Segoe UI" panose="020B0502040204020203" pitchFamily="34" charset="0"/>
+                <a:cs typeface="Segoe UI" panose="020B0502040204020203" pitchFamily="34" charset="0"/>
+              </a:rPr>
+              <a:t>")</a:t>
+            </a:r>
+          </a:p>
+          <a:p>
+            <a:r>
+              <a:rPr lang="en-US" dirty="0">
+                <a:latin typeface="Segoe UI" panose="020B0502040204020203" pitchFamily="34" charset="0"/>
+                <a:cs typeface="Segoe UI" panose="020B0502040204020203" pitchFamily="34" charset="0"/>
+              </a:rPr>
+              <a:t>Record custom metrics (e.g., number of destinations, planning duration)</a:t>
+            </a:r>
+          </a:p>
+          <a:p>
+            <a:r>
+              <a:rPr lang="en-US" dirty="0">
+                <a:latin typeface="Segoe UI" panose="020B0502040204020203" pitchFamily="34" charset="0"/>
+                <a:cs typeface="Segoe UI" panose="020B0502040204020203" pitchFamily="34" charset="0"/>
+              </a:rPr>
+              <a:t>Add structured logging context for better debugging</a:t>
+            </a:r>
+          </a:p>
+          <a:p>
+            <a:r>
+              <a:rPr lang="en-US" dirty="0">
+                <a:latin typeface="Segoe UI" panose="020B0502040204020203" pitchFamily="34" charset="0"/>
+                <a:cs typeface="Segoe UI" panose="020B0502040204020203" pitchFamily="34" charset="0"/>
+              </a:rPr>
+              <a:t>Correlate application events with AI agent activities</a:t>
+            </a:r>
+          </a:p>
+          <a:p>
+            <a:pPr marL="0" indent="0">
+              <a:buNone/>
+            </a:pPr>
+            <a:endParaRPr lang="en-US" dirty="0">
+              <a:latin typeface="Segoe UI" panose="020B0502040204020203" pitchFamily="34" charset="0"/>
+              <a:cs typeface="Segoe UI" panose="020B0502040204020203" pitchFamily="34" charset="0"/>
+            </a:endParaRPr>
+          </a:p>
+          <a:p>
+            <a:pPr marL="0" indent="0">
+              <a:buNone/>
+            </a:pPr>
+            <a:r>
+              <a:rPr lang="en-US" dirty="0">
+                <a:latin typeface="Segoe UI" panose="020B0502040204020203" pitchFamily="34" charset="0"/>
+                <a:cs typeface="Segoe UI" panose="020B0502040204020203" pitchFamily="34" charset="0"/>
+              </a:rPr>
+              <a:t>By the end of this challenge, you'll have visibility into both the automatic Agent Framework telemetry </a:t>
+            </a:r>
+            <a:r>
+              <a:rPr lang="en-US" b="1" dirty="0">
+                <a:latin typeface="Segoe UI" panose="020B0502040204020203" pitchFamily="34" charset="0"/>
+                <a:cs typeface="Segoe UI" panose="020B0502040204020203" pitchFamily="34" charset="0"/>
+              </a:rPr>
+              <a:t>and</a:t>
+            </a:r>
+            <a:r>
+              <a:rPr lang="en-US" dirty="0">
+                <a:latin typeface="Segoe UI" panose="020B0502040204020203" pitchFamily="34" charset="0"/>
+                <a:cs typeface="Segoe UI" panose="020B0502040204020203" pitchFamily="34" charset="0"/>
+              </a:rPr>
+              <a:t> your custom business logic, all flowing to New Relic.</a:t>
             </a:r>
           </a:p>
         </p:txBody>
@@ -10578,9 +10748,8 @@
                 <a:latin typeface="Segoe UI" panose="020B0502040204020203" pitchFamily="34" charset="0"/>
                 <a:cs typeface="Segoe UI" panose="020B0502040204020203" pitchFamily="34" charset="0"/>
               </a:rPr>
-              <a:t>Connect to New Relic - Time to see the full picture!</a:t>
-            </a:r>
-            <a:endParaRPr lang="en-US" dirty="0"/>
+              <a:t>Custom Telemetry - Add your own signals</a:t>
+            </a:r>
           </a:p>
         </p:txBody>
       </p:sp>
@@ -10723,126 +10892,120 @@
                 <a:latin typeface="Segoe UI" panose="020B0502040204020203" pitchFamily="34" charset="0"/>
                 <a:cs typeface="Segoe UI" panose="020B0502040204020203" pitchFamily="34" charset="0"/>
               </a:rPr>
-              <a:t>Your goal is to configure your application to send traces, metrics, and logs to New Relic using the </a:t>
-            </a:r>
-            <a:r>
-              <a:rPr lang="en-US" sz="2200" dirty="0" err="1">
-                <a:latin typeface="Segoe UI" panose="020B0502040204020203" pitchFamily="34" charset="0"/>
-                <a:cs typeface="Segoe UI" panose="020B0502040204020203" pitchFamily="34" charset="0"/>
-              </a:rPr>
-              <a:t>OpenTelemetry</a:t>
-            </a:r>
-            <a:r>
-              <a:rPr lang="en-US" sz="2200" dirty="0">
-                <a:latin typeface="Segoe UI" panose="020B0502040204020203" pitchFamily="34" charset="0"/>
-                <a:cs typeface="Segoe UI" panose="020B0502040204020203" pitchFamily="34" charset="0"/>
-              </a:rPr>
-              <a:t> Line Protocol (OTLP) exporter.</a:t>
-            </a:r>
-          </a:p>
-          <a:p>
-            <a:pPr marL="457200"/>
-            <a:r>
-              <a:rPr lang="en-US" sz="2200" b="1" dirty="0">
+              <a:t>Your goal is to add custom spans, metrics, and structured logging to your travel planning application:</a:t>
+            </a:r>
+          </a:p>
+          <a:p>
+            <a:pPr marL="0" indent="0">
+              <a:buNone/>
+            </a:pPr>
+            <a:endParaRPr lang="en-US" sz="2200" dirty="0">
+              <a:latin typeface="Segoe UI" panose="020B0502040204020203" pitchFamily="34" charset="0"/>
+              <a:cs typeface="Segoe UI" panose="020B0502040204020203" pitchFamily="34" charset="0"/>
+            </a:endParaRPr>
+          </a:p>
+          <a:p>
+            <a:pPr>
+              <a:lnSpc>
+                <a:spcPct val="70000"/>
+              </a:lnSpc>
+            </a:pPr>
+            <a:r>
+              <a:rPr lang="en-US" sz="2500" b="1" dirty="0">
                 <a:solidFill>
                   <a:srgbClr val="F6C243"/>
                 </a:solidFill>
               </a:rPr>
-              <a:t>Environment Configuration</a:t>
-            </a:r>
-          </a:p>
-          <a:p>
-            <a:pPr marL="914400" lvl="1"/>
-            <a:r>
-              <a:rPr lang="en-US" sz="2200" dirty="0"/>
-              <a:t>Configure the OTLP endpoint URL for your region (US or EU)</a:t>
-            </a:r>
-          </a:p>
-          <a:p>
-            <a:pPr marL="914400" lvl="1"/>
-            <a:r>
-              <a:rPr lang="en-US" sz="2200" dirty="0"/>
-              <a:t>Set up the authentication header with your New Relic License Key</a:t>
-            </a:r>
-          </a:p>
-          <a:p>
-            <a:pPr marL="914400" lvl="1"/>
-            <a:r>
-              <a:rPr lang="en-US" sz="2200" dirty="0"/>
-              <a:t>Configure service identification attributes</a:t>
-            </a:r>
-          </a:p>
-          <a:p>
-            <a:pPr marL="457200"/>
-            <a:r>
-              <a:rPr lang="en-US" sz="2200" b="1" dirty="0">
+              <a:t>Add Custom Spans</a:t>
+            </a:r>
+          </a:p>
+          <a:p>
+            <a:pPr lvl="1">
+              <a:lnSpc>
+                <a:spcPct val="70000"/>
+              </a:lnSpc>
+            </a:pPr>
+            <a:r>
+              <a:rPr lang="en-US" sz="2500" dirty="0"/>
+              <a:t>Instrument tool calls and business logic with manual spans</a:t>
+            </a:r>
+          </a:p>
+          <a:p>
+            <a:pPr>
+              <a:lnSpc>
+                <a:spcPct val="70000"/>
+              </a:lnSpc>
+            </a:pPr>
+            <a:r>
+              <a:rPr lang="en-US" sz="2500" b="1" dirty="0">
                 <a:solidFill>
                   <a:srgbClr val="F6C243"/>
                 </a:solidFill>
               </a:rPr>
-              <a:t>Update </a:t>
-            </a:r>
-            <a:r>
-              <a:rPr lang="en-US" sz="2200" b="1" dirty="0" err="1">
+              <a:t>Add Custom Metrics</a:t>
+            </a:r>
+          </a:p>
+          <a:p>
+            <a:pPr lvl="1">
+              <a:lnSpc>
+                <a:spcPct val="70000"/>
+              </a:lnSpc>
+            </a:pPr>
+            <a:r>
+              <a:rPr lang="en-US" sz="2500" dirty="0"/>
+              <a:t>Record meaningful measurements (trip planning duration, destination counts, etc.)</a:t>
+            </a:r>
+          </a:p>
+          <a:p>
+            <a:pPr>
+              <a:lnSpc>
+                <a:spcPct val="70000"/>
+              </a:lnSpc>
+            </a:pPr>
+            <a:r>
+              <a:rPr lang="en-US" sz="2500" b="1" dirty="0">
                 <a:solidFill>
                   <a:srgbClr val="F6C243"/>
                 </a:solidFill>
               </a:rPr>
-              <a:t>OpenTelemetry</a:t>
-            </a:r>
-            <a:r>
-              <a:rPr lang="en-US" sz="2200" b="1" dirty="0">
+              <a:t>Add Structured Logging</a:t>
+            </a:r>
+          </a:p>
+          <a:p>
+            <a:pPr lvl="1">
+              <a:lnSpc>
+                <a:spcPct val="70000"/>
+              </a:lnSpc>
+            </a:pPr>
+            <a:r>
+              <a:rPr lang="en-US" sz="2500" dirty="0"/>
+              <a:t>Correlate logs with spans using trace context</a:t>
+            </a:r>
+          </a:p>
+          <a:p>
+            <a:pPr>
+              <a:lnSpc>
+                <a:spcPct val="70000"/>
+              </a:lnSpc>
+            </a:pPr>
+            <a:r>
+              <a:rPr lang="en-US" sz="2500" b="1" dirty="0">
                 <a:solidFill>
                   <a:srgbClr val="F6C243"/>
                 </a:solidFill>
               </a:rPr>
-              <a:t> Initialization</a:t>
-            </a:r>
-          </a:p>
-          <a:p>
-            <a:pPr marL="914400" lvl="1"/>
-            <a:r>
-              <a:rPr lang="en-US" sz="2200" dirty="0"/>
-              <a:t>Replace the console exporter with the OTLP exporter</a:t>
-            </a:r>
-          </a:p>
-          <a:p>
-            <a:pPr marL="914400" lvl="1"/>
-            <a:r>
-              <a:rPr lang="en-US" sz="2200" dirty="0"/>
-              <a:t>(Configure exporters for traces, metrics, and logs)</a:t>
-            </a:r>
-          </a:p>
-          <a:p>
-            <a:pPr marL="457200"/>
-            <a:r>
-              <a:rPr lang="en-US" sz="2200" b="1" dirty="0">
-                <a:solidFill>
-                  <a:srgbClr val="F6C243"/>
-                </a:solidFill>
-              </a:rPr>
-              <a:t>Validate the Integration</a:t>
-            </a:r>
-          </a:p>
-          <a:p>
-            <a:pPr marL="914400" lvl="1"/>
-            <a:r>
-              <a:rPr lang="en-US" sz="2200" dirty="0"/>
-              <a:t>Make test requests to your application</a:t>
-            </a:r>
-          </a:p>
-          <a:p>
-            <a:pPr marL="914400" lvl="1"/>
-            <a:r>
-              <a:rPr lang="en-US" sz="2200" dirty="0"/>
-              <a:t>Verify traces appear in the New Relic UI</a:t>
-            </a:r>
-          </a:p>
-          <a:p>
-            <a:pPr marL="914400" lvl="1"/>
-            <a:r>
-              <a:rPr lang="en-US" sz="2200" dirty="0"/>
-              <a:t>Search and filter traces to confirm your data is flowing correctly</a:t>
+              <a:t>Verify in New Relic</a:t>
+            </a:r>
+          </a:p>
+          <a:p>
+            <a:pPr lvl="1">
+              <a:lnSpc>
+                <a:spcPct val="70000"/>
+              </a:lnSpc>
+            </a:pPr>
+            <a:r>
+              <a:rPr lang="en-US" sz="2500" dirty="0"/>
+              <a:t>Confirm custom telemetry appears alongside auto-generated signals</a:t>
             </a:r>
           </a:p>
         </p:txBody>
@@ -10870,7 +11033,7 @@
           <a:p>
             <a:r>
               <a:rPr lang="en-US" dirty="0"/>
-              <a:t>Connect to New Relic - Time to see the full picture!</a:t>
+              <a:t>Custom Telemetry - Add your own signals</a:t>
             </a:r>
           </a:p>
         </p:txBody>
@@ -16102,6 +16265,15 @@
 </file>
 
 <file path=customXml/item1.xml><?xml version="1.0" encoding="utf-8"?>
+<?mso-contentType ?>
+<FormTemplates xmlns="http://schemas.microsoft.com/sharepoint/v3/contenttype/forms">
+  <Display>DocumentLibraryForm</Display>
+  <Edit>DocumentLibraryForm</Edit>
+  <New>DocumentLibraryForm</New>
+</FormTemplates>
+</file>
+
+<file path=customXml/item2.xml><?xml version="1.0" encoding="utf-8"?>
 <p:properties xmlns:p="http://schemas.microsoft.com/office/2006/metadata/properties" xmlns:xsi="http://www.w3.org/2001/XMLSchema-instance" xmlns:pc="http://schemas.microsoft.com/office/infopath/2007/PartnerControls">
   <documentManagement>
     <_ip_UnifiedCompliancePolicyUIAction xmlns="http://schemas.microsoft.com/sharepoint/v3" xsi:nil="true"/>
@@ -16113,15 +16285,6 @@
     </lcf76f155ced4ddcb4097134ff3c332f>
   </documentManagement>
 </p:properties>
-</file>
-
-<file path=customXml/item2.xml><?xml version="1.0" encoding="utf-8"?>
-<?mso-contentType ?>
-<FormTemplates xmlns="http://schemas.microsoft.com/sharepoint/v3/contenttype/forms">
-  <Display>DocumentLibraryForm</Display>
-  <Edit>DocumentLibraryForm</Edit>
-  <New>DocumentLibraryForm</New>
-</FormTemplates>
 </file>
 
 <file path=customXml/item3.xml><?xml version="1.0" encoding="utf-8"?>
@@ -16398,6 +16561,14 @@
 </file>
 
 <file path=customXml/itemProps1.xml><?xml version="1.0" encoding="utf-8"?>
+<ds:datastoreItem xmlns:ds="http://schemas.openxmlformats.org/officeDocument/2006/customXml" ds:itemID="{FA84066F-CF25-477A-816A-71B1599BA426}">
+  <ds:schemaRefs>
+    <ds:schemaRef ds:uri="http://schemas.microsoft.com/sharepoint/v3/contenttype/forms"/>
+  </ds:schemaRefs>
+</ds:datastoreItem>
+</file>
+
+<file path=customXml/itemProps2.xml><?xml version="1.0" encoding="utf-8"?>
 <ds:datastoreItem xmlns:ds="http://schemas.openxmlformats.org/officeDocument/2006/customXml" ds:itemID="{FE1AEC35-FA48-4D92-B146-8AAF6D580B36}">
   <ds:schemaRefs>
     <ds:schemaRef ds:uri="http://schemas.microsoft.com/office/2006/documentManagement/types"/>
@@ -16412,14 +16583,6 @@
     <ds:schemaRef ds:uri="d5681aaf-e75d-4680-b6a5-67eaf1333073"/>
     <ds:schemaRef ds:uri="http://schemas.microsoft.com/sharepoint/v3"/>
     <ds:schemaRef ds:uri="http://purl.org/dc/elements/1.1/"/>
-  </ds:schemaRefs>
-</ds:datastoreItem>
-</file>
-
-<file path=customXml/itemProps2.xml><?xml version="1.0" encoding="utf-8"?>
-<ds:datastoreItem xmlns:ds="http://schemas.openxmlformats.org/officeDocument/2006/customXml" ds:itemID="{FA84066F-CF25-477A-816A-71B1599BA426}">
-  <ds:schemaRefs>
-    <ds:schemaRef ds:uri="http://schemas.microsoft.com/sharepoint/v3/contenttype/forms"/>
   </ds:schemaRefs>
 </ds:datastoreItem>
 </file>

</xml_diff>